<commit_message>
Add new PowerPoint presentation for AMCI summary on September 4, 2026
</commit_message>
<xml_diff>
--- a/main/slides_es/resumen-trabajo-amci-4-09-2026.pptx
+++ b/main/slides_es/resumen-trabajo-amci-4-09-2026.pptx
@@ -277,7 +277,7 @@
           <a:p>
             <a:fld id="{E7033D45-214F-4590-AE5F-D6D9CBF27883}" type="datetimeFigureOut">
               <a:rPr lang="es-CO" smtClean="0"/>
-              <a:t>7/09/2026</a:t>
+              <a:t>13/09/2026</a:t>
             </a:fld>
             <a:endParaRPr lang="es-CO"/>
           </a:p>
@@ -477,7 +477,7 @@
           <a:p>
             <a:fld id="{E7033D45-214F-4590-AE5F-D6D9CBF27883}" type="datetimeFigureOut">
               <a:rPr lang="es-CO" smtClean="0"/>
-              <a:t>7/09/2026</a:t>
+              <a:t>13/09/2026</a:t>
             </a:fld>
             <a:endParaRPr lang="es-CO"/>
           </a:p>
@@ -687,7 +687,7 @@
           <a:p>
             <a:fld id="{E7033D45-214F-4590-AE5F-D6D9CBF27883}" type="datetimeFigureOut">
               <a:rPr lang="es-CO" smtClean="0"/>
-              <a:t>7/09/2026</a:t>
+              <a:t>13/09/2026</a:t>
             </a:fld>
             <a:endParaRPr lang="es-CO"/>
           </a:p>
@@ -887,7 +887,7 @@
           <a:p>
             <a:fld id="{E7033D45-214F-4590-AE5F-D6D9CBF27883}" type="datetimeFigureOut">
               <a:rPr lang="es-CO" smtClean="0"/>
-              <a:t>7/09/2026</a:t>
+              <a:t>13/09/2026</a:t>
             </a:fld>
             <a:endParaRPr lang="es-CO"/>
           </a:p>
@@ -1163,7 +1163,7 @@
           <a:p>
             <a:fld id="{E7033D45-214F-4590-AE5F-D6D9CBF27883}" type="datetimeFigureOut">
               <a:rPr lang="es-CO" smtClean="0"/>
-              <a:t>7/09/2026</a:t>
+              <a:t>13/09/2026</a:t>
             </a:fld>
             <a:endParaRPr lang="es-CO"/>
           </a:p>
@@ -1431,7 +1431,7 @@
           <a:p>
             <a:fld id="{E7033D45-214F-4590-AE5F-D6D9CBF27883}" type="datetimeFigureOut">
               <a:rPr lang="es-CO" smtClean="0"/>
-              <a:t>7/09/2026</a:t>
+              <a:t>13/09/2026</a:t>
             </a:fld>
             <a:endParaRPr lang="es-CO"/>
           </a:p>
@@ -1846,7 +1846,7 @@
           <a:p>
             <a:fld id="{E7033D45-214F-4590-AE5F-D6D9CBF27883}" type="datetimeFigureOut">
               <a:rPr lang="es-CO" smtClean="0"/>
-              <a:t>7/09/2026</a:t>
+              <a:t>13/09/2026</a:t>
             </a:fld>
             <a:endParaRPr lang="es-CO"/>
           </a:p>
@@ -1988,7 +1988,7 @@
           <a:p>
             <a:fld id="{E7033D45-214F-4590-AE5F-D6D9CBF27883}" type="datetimeFigureOut">
               <a:rPr lang="es-CO" smtClean="0"/>
-              <a:t>7/09/2026</a:t>
+              <a:t>13/09/2026</a:t>
             </a:fld>
             <a:endParaRPr lang="es-CO"/>
           </a:p>
@@ -2101,7 +2101,7 @@
           <a:p>
             <a:fld id="{E7033D45-214F-4590-AE5F-D6D9CBF27883}" type="datetimeFigureOut">
               <a:rPr lang="es-CO" smtClean="0"/>
-              <a:t>7/09/2026</a:t>
+              <a:t>13/09/2026</a:t>
             </a:fld>
             <a:endParaRPr lang="es-CO"/>
           </a:p>
@@ -2414,7 +2414,7 @@
           <a:p>
             <a:fld id="{E7033D45-214F-4590-AE5F-D6D9CBF27883}" type="datetimeFigureOut">
               <a:rPr lang="es-CO" smtClean="0"/>
-              <a:t>7/09/2026</a:t>
+              <a:t>13/09/2026</a:t>
             </a:fld>
             <a:endParaRPr lang="es-CO"/>
           </a:p>
@@ -2703,7 +2703,7 @@
           <a:p>
             <a:fld id="{E7033D45-214F-4590-AE5F-D6D9CBF27883}" type="datetimeFigureOut">
               <a:rPr lang="es-CO" smtClean="0"/>
-              <a:t>7/09/2026</a:t>
+              <a:t>13/09/2026</a:t>
             </a:fld>
             <a:endParaRPr lang="es-CO"/>
           </a:p>
@@ -2949,7 +2949,7 @@
           <a:p>
             <a:fld id="{E7033D45-214F-4590-AE5F-D6D9CBF27883}" type="datetimeFigureOut">
               <a:rPr lang="es-CO" smtClean="0"/>
-              <a:t>7/09/2026</a:t>
+              <a:t>13/09/2026</a:t>
             </a:fld>
             <a:endParaRPr lang="es-CO"/>
           </a:p>
@@ -3352,6 +3352,14 @@
 <file path=ppt/slides/slide1.xml><?xml version="1.0" encoding="utf-8"?>
 <p:sld xmlns:a="http://schemas.openxmlformats.org/drawingml/2006/main" xmlns:r="http://schemas.openxmlformats.org/officeDocument/2006/relationships" xmlns:p="http://schemas.openxmlformats.org/presentationml/2006/main">
   <p:cSld>
+    <p:bg>
+      <p:bgPr>
+        <a:solidFill>
+          <a:srgbClr val="F7F3E8"/>
+        </a:solidFill>
+        <a:effectLst/>
+      </p:bgPr>
+    </p:bg>
     <p:spTree>
       <p:nvGrpSpPr>
         <p:cNvPr id="1" name=""/>
@@ -3380,7 +3388,7 @@
         </p:nvSpPr>
         <p:spPr>
           <a:xfrm>
-            <a:off x="1199121" y="1315628"/>
+            <a:off x="1333500" y="736702"/>
             <a:ext cx="9525000" cy="1569660"/>
           </a:xfrm>
           <a:prstGeom prst="rect">
@@ -3431,8 +3439,8 @@
         </p:nvSpPr>
         <p:spPr>
           <a:xfrm>
-            <a:off x="4107808" y="3804769"/>
-            <a:ext cx="3976383" cy="1815882"/>
+            <a:off x="1093100" y="3429000"/>
+            <a:ext cx="3061982" cy="2062103"/>
           </a:xfrm>
           <a:prstGeom prst="rect">
             <a:avLst/>
@@ -3445,63 +3453,57 @@
           </a:bodyPr>
           <a:lstStyle/>
           <a:p>
-            <a:pPr algn="ctr"/>
             <a:r>
               <a:rPr lang="es-MX" sz="1600" dirty="0">
-                <a:latin typeface="xkcd Script" panose="03000503000000000000" pitchFamily="66" charset="0"/>
-                <a:ea typeface="xkcd Script" panose="03000503000000000000" pitchFamily="66" charset="0"/>
+                <a:latin typeface="Montserrat" pitchFamily="2" charset="0"/>
+                <a:ea typeface="Open Sans" pitchFamily="2" charset="0"/>
                 <a:cs typeface="Open Sans" pitchFamily="2" charset="0"/>
               </a:rPr>
               <a:t>Oscar Andrés Rincón Cardeño</a:t>
             </a:r>
           </a:p>
           <a:p>
-            <a:pPr algn="ctr"/>
             <a:r>
               <a:rPr lang="es-MX" sz="1600" dirty="0">
-                <a:latin typeface="xkcd Script" panose="03000503000000000000" pitchFamily="66" charset="0"/>
-                <a:ea typeface="xkcd Script" panose="03000503000000000000" pitchFamily="66" charset="0"/>
+                <a:latin typeface="Montserrat" pitchFamily="2" charset="0"/>
+                <a:ea typeface="Open Sans" pitchFamily="2" charset="0"/>
                 <a:cs typeface="Open Sans" pitchFamily="2" charset="0"/>
               </a:rPr>
               <a:t>Doctorado en Ingeniería</a:t>
             </a:r>
           </a:p>
           <a:p>
-            <a:pPr algn="ctr"/>
             <a:endParaRPr lang="es-MX" sz="1600" dirty="0">
-              <a:latin typeface="xkcd Script" panose="03000503000000000000" pitchFamily="66" charset="0"/>
-              <a:ea typeface="xkcd Script" panose="03000503000000000000" pitchFamily="66" charset="0"/>
+              <a:latin typeface="Montserrat" pitchFamily="2" charset="0"/>
+              <a:ea typeface="Open Sans" pitchFamily="2" charset="0"/>
               <a:cs typeface="Open Sans" pitchFamily="2" charset="0"/>
             </a:endParaRPr>
           </a:p>
           <a:p>
-            <a:pPr algn="ctr"/>
             <a:r>
               <a:rPr lang="es-MX" sz="1600" dirty="0">
-                <a:latin typeface="xkcd Script" panose="03000503000000000000" pitchFamily="66" charset="0"/>
-                <a:ea typeface="xkcd Script" panose="03000503000000000000" pitchFamily="66" charset="0"/>
+                <a:latin typeface="Montserrat" pitchFamily="2" charset="0"/>
+                <a:ea typeface="Open Sans" pitchFamily="2" charset="0"/>
                 <a:cs typeface="Open Sans" pitchFamily="2" charset="0"/>
               </a:rPr>
               <a:t>Aplicaciones Matemáticas en Ciencia e Ingeniería </a:t>
             </a:r>
           </a:p>
           <a:p>
-            <a:pPr algn="ctr"/>
             <a:r>
               <a:rPr lang="es-MX" sz="1600" dirty="0">
-                <a:latin typeface="xkcd Script" panose="03000503000000000000" pitchFamily="66" charset="0"/>
-                <a:ea typeface="xkcd Script" panose="03000503000000000000" pitchFamily="66" charset="0"/>
+                <a:latin typeface="Montserrat" pitchFamily="2" charset="0"/>
+                <a:ea typeface="Open Sans" pitchFamily="2" charset="0"/>
                 <a:cs typeface="Open Sans" pitchFamily="2" charset="0"/>
               </a:rPr>
               <a:t>Universidad EAFIT </a:t>
             </a:r>
           </a:p>
           <a:p>
-            <a:pPr algn="ctr"/>
             <a:r>
               <a:rPr lang="es-CO" sz="1600" dirty="0">
-                <a:latin typeface="xkcd Script" panose="03000503000000000000" pitchFamily="66" charset="0"/>
-                <a:ea typeface="xkcd Script" panose="03000503000000000000" pitchFamily="66" charset="0"/>
+                <a:latin typeface="Montserrat" pitchFamily="2" charset="0"/>
+                <a:ea typeface="Open Sans" pitchFamily="2" charset="0"/>
                 <a:cs typeface="Open Sans" pitchFamily="2" charset="0"/>
               </a:rPr>
               <a:t>Septiembre del 2026</a:t>
@@ -3509,6 +3511,42 @@
           </a:p>
         </p:txBody>
       </p:sp>
+      <p:pic>
+        <p:nvPicPr>
+          <p:cNvPr id="3" name="Gráfico 2">
+            <a:extLst>
+              <a:ext uri="{FF2B5EF4-FFF2-40B4-BE49-F238E27FC236}">
+                <a16:creationId xmlns:a16="http://schemas.microsoft.com/office/drawing/2014/main" id="{4B602910-8049-7E21-C40B-98025C142179}"/>
+              </a:ext>
+            </a:extLst>
+          </p:cNvPr>
+          <p:cNvPicPr>
+            <a:picLocks noChangeAspect="1"/>
+          </p:cNvPicPr>
+          <p:nvPr/>
+        </p:nvPicPr>
+        <p:blipFill>
+          <a:blip r:embed="rId2">
+            <a:extLst>
+              <a:ext uri="{96DAC541-7B7A-43D3-8B79-37D633B846F1}">
+                <asvg:svgBlip xmlns:asvg="http://schemas.microsoft.com/office/drawing/2016/SVG/main" r:embed="rId3"/>
+              </a:ext>
+            </a:extLst>
+          </a:blip>
+          <a:stretch>
+            <a:fillRect/>
+          </a:stretch>
+        </p:blipFill>
+        <p:spPr>
+          <a:xfrm>
+            <a:off x="4991100" y="3389589"/>
+            <a:ext cx="6107800" cy="2352250"/>
+          </a:xfrm>
+          <a:prstGeom prst="rect">
+            <a:avLst/>
+          </a:prstGeom>
+        </p:spPr>
+      </p:pic>
     </p:spTree>
     <p:extLst>
       <p:ext uri="{BB962C8B-B14F-4D97-AF65-F5344CB8AC3E}">
@@ -3554,7 +3592,7 @@
         <p:spPr>
           <a:xfrm>
             <a:off x="668337" y="3113362"/>
-            <a:ext cx="2825362" cy="2031325"/>
+            <a:ext cx="2825362" cy="2462213"/>
           </a:xfrm>
           <a:prstGeom prst="rect">
             <a:avLst/>
@@ -3569,9 +3607,9 @@
           <a:p>
             <a:r>
               <a:rPr lang="es-ES" sz="1400" dirty="0">
-                <a:latin typeface="xkcd Script" panose="03000503000000000000" pitchFamily="66" charset="0"/>
-                <a:ea typeface="xkcd Script" panose="03000503000000000000" pitchFamily="66" charset="0"/>
-                <a:cs typeface="Segoe UI" panose="020B0502040204020203" pitchFamily="34" charset="0"/>
+                <a:latin typeface="Open Sans" pitchFamily="2" charset="0"/>
+                <a:ea typeface="Open Sans" pitchFamily="2" charset="0"/>
+                <a:cs typeface="Open Sans" pitchFamily="2" charset="0"/>
               </a:rPr>
               <a:t>Se concibe como un continuo que va desde </a:t>
             </a:r>
@@ -3580,17 +3618,17 @@
                 <a:solidFill>
                   <a:srgbClr val="0070C0"/>
                 </a:solidFill>
-                <a:latin typeface="xkcd Script" panose="03000503000000000000" pitchFamily="66" charset="0"/>
-                <a:ea typeface="xkcd Script" panose="03000503000000000000" pitchFamily="66" charset="0"/>
-                <a:cs typeface="Segoe UI" panose="020B0502040204020203" pitchFamily="34" charset="0"/>
+                <a:latin typeface="Open Sans" pitchFamily="2" charset="0"/>
+                <a:ea typeface="Open Sans" pitchFamily="2" charset="0"/>
+                <a:cs typeface="Open Sans" pitchFamily="2" charset="0"/>
               </a:rPr>
               <a:t>modelos puramente basados ​​en datos </a:t>
             </a:r>
             <a:r>
               <a:rPr lang="es-ES" sz="1400" dirty="0">
-                <a:latin typeface="xkcd Script" panose="03000503000000000000" pitchFamily="66" charset="0"/>
-                <a:ea typeface="xkcd Script" panose="03000503000000000000" pitchFamily="66" charset="0"/>
-                <a:cs typeface="Segoe UI" panose="020B0502040204020203" pitchFamily="34" charset="0"/>
+                <a:latin typeface="Open Sans" pitchFamily="2" charset="0"/>
+                <a:ea typeface="Open Sans" pitchFamily="2" charset="0"/>
+                <a:cs typeface="Open Sans" pitchFamily="2" charset="0"/>
               </a:rPr>
               <a:t>hasta modelos </a:t>
             </a:r>
@@ -3599,17 +3637,17 @@
                 <a:solidFill>
                   <a:srgbClr val="0070C0"/>
                 </a:solidFill>
-                <a:latin typeface="xkcd Script" panose="03000503000000000000" pitchFamily="66" charset="0"/>
-                <a:ea typeface="xkcd Script" panose="03000503000000000000" pitchFamily="66" charset="0"/>
-                <a:cs typeface="Segoe UI" panose="020B0502040204020203" pitchFamily="34" charset="0"/>
+                <a:latin typeface="Open Sans" pitchFamily="2" charset="0"/>
+                <a:ea typeface="Open Sans" pitchFamily="2" charset="0"/>
+                <a:cs typeface="Open Sans" pitchFamily="2" charset="0"/>
               </a:rPr>
               <a:t>totalmente basados ​​en la física</a:t>
             </a:r>
             <a:r>
               <a:rPr lang="es-ES" sz="1400" dirty="0">
-                <a:latin typeface="xkcd Script" panose="03000503000000000000" pitchFamily="66" charset="0"/>
-                <a:ea typeface="xkcd Script" panose="03000503000000000000" pitchFamily="66" charset="0"/>
-                <a:cs typeface="Segoe UI" panose="020B0502040204020203" pitchFamily="34" charset="0"/>
+                <a:latin typeface="Open Sans" pitchFamily="2" charset="0"/>
+                <a:ea typeface="Open Sans" pitchFamily="2" charset="0"/>
+                <a:cs typeface="Open Sans" pitchFamily="2" charset="0"/>
               </a:rPr>
               <a:t>, con los tres mecanismos de sesgo </a:t>
             </a:r>
@@ -3618,24 +3656,24 @@
                 <a:solidFill>
                   <a:srgbClr val="0070C0"/>
                 </a:solidFill>
-                <a:latin typeface="xkcd Script" panose="03000503000000000000" pitchFamily="66" charset="0"/>
-                <a:ea typeface="xkcd Script" panose="03000503000000000000" pitchFamily="66" charset="0"/>
-                <a:cs typeface="Segoe UI" panose="020B0502040204020203" pitchFamily="34" charset="0"/>
+                <a:latin typeface="Open Sans" pitchFamily="2" charset="0"/>
+                <a:ea typeface="Open Sans" pitchFamily="2" charset="0"/>
+                <a:cs typeface="Open Sans" pitchFamily="2" charset="0"/>
               </a:rPr>
               <a:t>(inductivo, observacional y de aprendizaje) </a:t>
             </a:r>
             <a:r>
               <a:rPr lang="es-ES" sz="1400" dirty="0">
-                <a:latin typeface="xkcd Script" panose="03000503000000000000" pitchFamily="66" charset="0"/>
-                <a:ea typeface="xkcd Script" panose="03000503000000000000" pitchFamily="66" charset="0"/>
-                <a:cs typeface="Segoe UI" panose="020B0502040204020203" pitchFamily="34" charset="0"/>
+                <a:latin typeface="Open Sans" pitchFamily="2" charset="0"/>
+                <a:ea typeface="Open Sans" pitchFamily="2" charset="0"/>
+                <a:cs typeface="Open Sans" pitchFamily="2" charset="0"/>
               </a:rPr>
               <a:t>posicionados según el punto donde interviene en el procedimiento de entrenamiento</a:t>
             </a:r>
             <a:endParaRPr lang="es-MX" sz="1400" dirty="0">
-              <a:latin typeface="xkcd Script" panose="03000503000000000000" pitchFamily="66" charset="0"/>
-              <a:ea typeface="xkcd Script" panose="03000503000000000000" pitchFamily="66" charset="0"/>
-              <a:cs typeface="Segoe UI" panose="020B0502040204020203" pitchFamily="34" charset="0"/>
+              <a:latin typeface="Open Sans" pitchFamily="2" charset="0"/>
+              <a:ea typeface="Open Sans" pitchFamily="2" charset="0"/>
+              <a:cs typeface="Open Sans" pitchFamily="2" charset="0"/>
             </a:endParaRPr>
           </a:p>
         </p:txBody>
@@ -3717,8 +3755,44 @@
         </p:blipFill>
         <p:spPr>
           <a:xfrm>
-            <a:off x="4258237" y="696571"/>
+            <a:off x="4239187" y="639421"/>
             <a:ext cx="6849032" cy="5231776"/>
+          </a:xfrm>
+          <a:prstGeom prst="rect">
+            <a:avLst/>
+          </a:prstGeom>
+        </p:spPr>
+      </p:pic>
+      <p:pic>
+        <p:nvPicPr>
+          <p:cNvPr id="12" name="Gráfico 11">
+            <a:extLst>
+              <a:ext uri="{FF2B5EF4-FFF2-40B4-BE49-F238E27FC236}">
+                <a16:creationId xmlns:a16="http://schemas.microsoft.com/office/drawing/2014/main" id="{F3078714-3B33-426C-D29E-360BEA0339C6}"/>
+              </a:ext>
+            </a:extLst>
+          </p:cNvPr>
+          <p:cNvPicPr>
+            <a:picLocks noChangeAspect="1"/>
+          </p:cNvPicPr>
+          <p:nvPr/>
+        </p:nvPicPr>
+        <p:blipFill>
+          <a:blip r:embed="rId3">
+            <a:extLst>
+              <a:ext uri="{96DAC541-7B7A-43D3-8B79-37D633B846F1}">
+                <asvg:svgBlip xmlns:asvg="http://schemas.microsoft.com/office/drawing/2016/SVG/main" r:embed="rId4"/>
+              </a:ext>
+            </a:extLst>
+          </a:blip>
+          <a:stretch>
+            <a:fillRect/>
+          </a:stretch>
+        </p:blipFill>
+        <p:spPr>
+          <a:xfrm flipH="1" flipV="1">
+            <a:off x="8686800" y="6256679"/>
+            <a:ext cx="3314700" cy="524376"/>
           </a:xfrm>
           <a:prstGeom prst="rect">
             <a:avLst/>
@@ -3816,7 +3890,7 @@
         <p:spPr>
           <a:xfrm>
             <a:off x="902927" y="2893191"/>
-            <a:ext cx="2853906" cy="2462213"/>
+            <a:ext cx="2853906" cy="2893100"/>
           </a:xfrm>
           <a:prstGeom prst="rect">
             <a:avLst/>
@@ -3834,16 +3908,16 @@
                 <a:solidFill>
                   <a:srgbClr val="0070C0"/>
                 </a:solidFill>
-                <a:latin typeface="xkcd Script" panose="03000503000000000000" pitchFamily="66" charset="0"/>
-                <a:ea typeface="xkcd Script" panose="03000503000000000000" pitchFamily="66" charset="0"/>
+                <a:latin typeface="Montserrat" pitchFamily="2" charset="0"/>
+                <a:ea typeface="Open Sans" pitchFamily="2" charset="0"/>
                 <a:cs typeface="Open Sans" pitchFamily="2" charset="0"/>
               </a:rPr>
               <a:t>1) </a:t>
             </a:r>
             <a:r>
               <a:rPr lang="es-CO" sz="1400" dirty="0">
-                <a:latin typeface="xkcd Script" panose="03000503000000000000" pitchFamily="66" charset="0"/>
-                <a:ea typeface="xkcd Script" panose="03000503000000000000" pitchFamily="66" charset="0"/>
+                <a:latin typeface="Montserrat" pitchFamily="2" charset="0"/>
+                <a:ea typeface="Open Sans" pitchFamily="2" charset="0"/>
                 <a:cs typeface="Open Sans" pitchFamily="2" charset="0"/>
               </a:rPr>
               <a:t>Aproximación de la solución en </a:t>
@@ -3853,16 +3927,16 @@
                 <a:solidFill>
                   <a:srgbClr val="0070C0"/>
                 </a:solidFill>
-                <a:latin typeface="xkcd Script" panose="03000503000000000000" pitchFamily="66" charset="0"/>
-                <a:ea typeface="xkcd Script" panose="03000503000000000000" pitchFamily="66" charset="0"/>
+                <a:latin typeface="Montserrat" pitchFamily="2" charset="0"/>
+                <a:ea typeface="Open Sans" pitchFamily="2" charset="0"/>
                 <a:cs typeface="Open Sans" pitchFamily="2" charset="0"/>
               </a:rPr>
               <a:t>ausencia de información </a:t>
             </a:r>
             <a:r>
               <a:rPr lang="es-CO" sz="1400" dirty="0">
-                <a:latin typeface="xkcd Script" panose="03000503000000000000" pitchFamily="66" charset="0"/>
-                <a:ea typeface="xkcd Script" panose="03000503000000000000" pitchFamily="66" charset="0"/>
+                <a:latin typeface="Montserrat" pitchFamily="2" charset="0"/>
+                <a:ea typeface="Open Sans" pitchFamily="2" charset="0"/>
                 <a:cs typeface="Open Sans" pitchFamily="2" charset="0"/>
               </a:rPr>
               <a:t>explícita</a:t>
@@ -3872,8 +3946,8 @@
                 <a:solidFill>
                   <a:srgbClr val="0070C0"/>
                 </a:solidFill>
-                <a:latin typeface="xkcd Script" panose="03000503000000000000" pitchFamily="66" charset="0"/>
-                <a:ea typeface="xkcd Script" panose="03000503000000000000" pitchFamily="66" charset="0"/>
+                <a:latin typeface="Montserrat" pitchFamily="2" charset="0"/>
+                <a:ea typeface="Open Sans" pitchFamily="2" charset="0"/>
                 <a:cs typeface="Open Sans" pitchFamily="2" charset="0"/>
               </a:rPr>
               <a:t> sobre las fronteras</a:t>
@@ -3884,8 +3958,8 @@
               <a:solidFill>
                 <a:srgbClr val="0070C0"/>
               </a:solidFill>
-              <a:latin typeface="xkcd Script" panose="03000503000000000000" pitchFamily="66" charset="0"/>
-              <a:ea typeface="xkcd Script" panose="03000503000000000000" pitchFamily="66" charset="0"/>
+              <a:latin typeface="Montserrat" pitchFamily="2" charset="0"/>
+              <a:ea typeface="Open Sans" pitchFamily="2" charset="0"/>
               <a:cs typeface="Open Sans" pitchFamily="2" charset="0"/>
             </a:endParaRPr>
           </a:p>
@@ -3895,16 +3969,16 @@
                 <a:solidFill>
                   <a:srgbClr val="0070C0"/>
                 </a:solidFill>
-                <a:latin typeface="xkcd Script" panose="03000503000000000000" pitchFamily="66" charset="0"/>
-                <a:ea typeface="xkcd Script" panose="03000503000000000000" pitchFamily="66" charset="0"/>
+                <a:latin typeface="Montserrat" pitchFamily="2" charset="0"/>
+                <a:ea typeface="Open Sans" pitchFamily="2" charset="0"/>
                 <a:cs typeface="Open Sans" pitchFamily="2" charset="0"/>
               </a:rPr>
               <a:t>2) </a:t>
             </a:r>
             <a:r>
               <a:rPr lang="es-CO" sz="1400" dirty="0">
-                <a:latin typeface="xkcd Script" panose="03000503000000000000" pitchFamily="66" charset="0"/>
-                <a:ea typeface="xkcd Script" panose="03000503000000000000" pitchFamily="66" charset="0"/>
+                <a:latin typeface="Montserrat" pitchFamily="2" charset="0"/>
+                <a:ea typeface="Open Sans" pitchFamily="2" charset="0"/>
                 <a:cs typeface="Open Sans" pitchFamily="2" charset="0"/>
               </a:rPr>
               <a:t>Recuperación de </a:t>
@@ -3914,8 +3988,8 @@
                 <a:solidFill>
                   <a:srgbClr val="0070C0"/>
                 </a:solidFill>
-                <a:latin typeface="xkcd Script" panose="03000503000000000000" pitchFamily="66" charset="0"/>
-                <a:ea typeface="xkcd Script" panose="03000503000000000000" pitchFamily="66" charset="0"/>
+                <a:latin typeface="Montserrat" pitchFamily="2" charset="0"/>
+                <a:ea typeface="Open Sans" pitchFamily="2" charset="0"/>
                 <a:cs typeface="Open Sans" pitchFamily="2" charset="0"/>
               </a:rPr>
               <a:t>coeficientes </a:t>
@@ -3925,8 +3999,8 @@
                 <a:solidFill>
                   <a:srgbClr val="0070C0"/>
                 </a:solidFill>
-                <a:latin typeface="xkcd Script" panose="03000503000000000000" pitchFamily="66" charset="0"/>
-                <a:ea typeface="xkcd Script" panose="03000503000000000000" pitchFamily="66" charset="0"/>
+                <a:latin typeface="Montserrat" pitchFamily="2" charset="0"/>
+                <a:ea typeface="Open Sans" pitchFamily="2" charset="0"/>
                 <a:cs typeface="Open Sans" pitchFamily="2" charset="0"/>
               </a:rPr>
               <a:t>k</a:t>
@@ -3936,16 +4010,16 @@
                 <a:solidFill>
                   <a:srgbClr val="0070C0"/>
                 </a:solidFill>
-                <a:latin typeface="xkcd Script" panose="03000503000000000000" pitchFamily="66" charset="0"/>
-                <a:ea typeface="xkcd Script" panose="03000503000000000000" pitchFamily="66" charset="0"/>
+                <a:latin typeface="Montserrat" pitchFamily="2" charset="0"/>
+                <a:ea typeface="Open Sans" pitchFamily="2" charset="0"/>
                 <a:cs typeface="Open Sans" pitchFamily="2" charset="0"/>
               </a:rPr>
               <a:t> </a:t>
             </a:r>
             <a:r>
               <a:rPr lang="es-CO" sz="1400" dirty="0">
-                <a:latin typeface="xkcd Script" panose="03000503000000000000" pitchFamily="66" charset="0"/>
-                <a:ea typeface="xkcd Script" panose="03000503000000000000" pitchFamily="66" charset="0"/>
+                <a:latin typeface="Montserrat" pitchFamily="2" charset="0"/>
+                <a:ea typeface="Open Sans" pitchFamily="2" charset="0"/>
                 <a:cs typeface="Open Sans" pitchFamily="2" charset="0"/>
               </a:rPr>
               <a:t>desconocidos que varían espacialmente </a:t>
@@ -3956,8 +4030,8 @@
               <a:solidFill>
                 <a:srgbClr val="0070C0"/>
               </a:solidFill>
-              <a:latin typeface="xkcd Script" panose="03000503000000000000" pitchFamily="66" charset="0"/>
-              <a:ea typeface="xkcd Script" panose="03000503000000000000" pitchFamily="66" charset="0"/>
+              <a:latin typeface="Montserrat" pitchFamily="2" charset="0"/>
+              <a:ea typeface="Open Sans" pitchFamily="2" charset="0"/>
               <a:cs typeface="Open Sans" pitchFamily="2" charset="0"/>
             </a:endParaRPr>
           </a:p>
@@ -3967,16 +4041,16 @@
                 <a:solidFill>
                   <a:srgbClr val="0070C0"/>
                 </a:solidFill>
-                <a:latin typeface="xkcd Script" panose="03000503000000000000" pitchFamily="66" charset="0"/>
-                <a:ea typeface="xkcd Script" panose="03000503000000000000" pitchFamily="66" charset="0"/>
+                <a:latin typeface="Montserrat" pitchFamily="2" charset="0"/>
+                <a:ea typeface="Open Sans" pitchFamily="2" charset="0"/>
                 <a:cs typeface="Open Sans" pitchFamily="2" charset="0"/>
               </a:rPr>
               <a:t>3) </a:t>
             </a:r>
             <a:r>
               <a:rPr lang="es-CO" sz="1400" dirty="0">
-                <a:latin typeface="xkcd Script" panose="03000503000000000000" pitchFamily="66" charset="0"/>
-                <a:ea typeface="xkcd Script" panose="03000503000000000000" pitchFamily="66" charset="0"/>
+                <a:latin typeface="Montserrat" pitchFamily="2" charset="0"/>
+                <a:ea typeface="Open Sans" pitchFamily="2" charset="0"/>
                 <a:cs typeface="Open Sans" pitchFamily="2" charset="0"/>
               </a:rPr>
               <a:t>Representación del comportamiento de la solución </a:t>
@@ -3986,8 +4060,8 @@
                 <a:solidFill>
                   <a:srgbClr val="0070C0"/>
                 </a:solidFill>
-                <a:latin typeface="xkcd Script" panose="03000503000000000000" pitchFamily="66" charset="0"/>
-                <a:ea typeface="xkcd Script" panose="03000503000000000000" pitchFamily="66" charset="0"/>
+                <a:latin typeface="Montserrat" pitchFamily="2" charset="0"/>
+                <a:ea typeface="Open Sans" pitchFamily="2" charset="0"/>
                 <a:cs typeface="Open Sans" pitchFamily="2" charset="0"/>
               </a:rPr>
               <a:t>fuera de la región de entrenamiento</a:t>
@@ -4023,8 +4097,44 @@
         </p:blipFill>
         <p:spPr>
           <a:xfrm>
-            <a:off x="4356847" y="842011"/>
+            <a:off x="4366372" y="958552"/>
             <a:ext cx="7117602" cy="4940896"/>
+          </a:xfrm>
+          <a:prstGeom prst="rect">
+            <a:avLst/>
+          </a:prstGeom>
+        </p:spPr>
+      </p:pic>
+      <p:pic>
+        <p:nvPicPr>
+          <p:cNvPr id="2" name="Gráfico 1">
+            <a:extLst>
+              <a:ext uri="{FF2B5EF4-FFF2-40B4-BE49-F238E27FC236}">
+                <a16:creationId xmlns:a16="http://schemas.microsoft.com/office/drawing/2014/main" id="{92443098-0267-CE68-26FD-F0D4EFFAF67D}"/>
+              </a:ext>
+            </a:extLst>
+          </p:cNvPr>
+          <p:cNvPicPr>
+            <a:picLocks noChangeAspect="1"/>
+          </p:cNvPicPr>
+          <p:nvPr/>
+        </p:nvPicPr>
+        <p:blipFill>
+          <a:blip r:embed="rId3">
+            <a:extLst>
+              <a:ext uri="{96DAC541-7B7A-43D3-8B79-37D633B846F1}">
+                <asvg:svgBlip xmlns:asvg="http://schemas.microsoft.com/office/drawing/2016/SVG/main" r:embed="rId4"/>
+              </a:ext>
+            </a:extLst>
+          </a:blip>
+          <a:stretch>
+            <a:fillRect/>
+          </a:stretch>
+        </p:blipFill>
+        <p:spPr>
+          <a:xfrm flipH="1" flipV="1">
+            <a:off x="8686800" y="6256679"/>
+            <a:ext cx="3314700" cy="524376"/>
           </a:xfrm>
           <a:prstGeom prst="rect">
             <a:avLst/>
@@ -4082,7 +4192,7 @@
         <p:spPr>
           <a:xfrm>
             <a:off x="706349" y="2337896"/>
-            <a:ext cx="2944318" cy="1815882"/>
+            <a:ext cx="2944318" cy="2246769"/>
           </a:xfrm>
           <a:prstGeom prst="rect">
             <a:avLst/>
@@ -4097,8 +4207,9 @@
           <a:p>
             <a:r>
               <a:rPr lang="es-CO" sz="1400" dirty="0">
-                <a:latin typeface="xkcd Script" panose="03000503000000000000" pitchFamily="66" charset="0"/>
-                <a:ea typeface="xkcd Script" panose="03000503000000000000" pitchFamily="66" charset="0"/>
+                <a:latin typeface="Open Sans" pitchFamily="2" charset="0"/>
+                <a:ea typeface="Open Sans" pitchFamily="2" charset="0"/>
+                <a:cs typeface="Open Sans" pitchFamily="2" charset="0"/>
               </a:rPr>
               <a:t>Dado que el dominio computacional no puede muestrearse uniformemente en una región infinita, </a:t>
             </a:r>
@@ -4107,15 +4218,17 @@
                 <a:solidFill>
                   <a:srgbClr val="0070C0"/>
                 </a:solidFill>
-                <a:latin typeface="xkcd Script" panose="03000503000000000000" pitchFamily="66" charset="0"/>
-                <a:ea typeface="xkcd Script" panose="03000503000000000000" pitchFamily="66" charset="0"/>
+                <a:latin typeface="Open Sans" pitchFamily="2" charset="0"/>
+                <a:ea typeface="Open Sans" pitchFamily="2" charset="0"/>
+                <a:cs typeface="Open Sans" pitchFamily="2" charset="0"/>
               </a:rPr>
               <a:t>la elección de los puntos de colocación resulta crucial </a:t>
             </a:r>
             <a:r>
               <a:rPr lang="es-CO" sz="1400" dirty="0">
-                <a:latin typeface="xkcd Script" panose="03000503000000000000" pitchFamily="66" charset="0"/>
-                <a:ea typeface="xkcd Script" panose="03000503000000000000" pitchFamily="66" charset="0"/>
+                <a:latin typeface="Open Sans" pitchFamily="2" charset="0"/>
+                <a:ea typeface="Open Sans" pitchFamily="2" charset="0"/>
+                <a:cs typeface="Open Sans" pitchFamily="2" charset="0"/>
               </a:rPr>
               <a:t>para representar con precisión tanto la región donde la solución presenta variaciones significativas como su comportamiento asintótico</a:t>
             </a:r>
@@ -4192,6 +4305,42 @@
           <a:xfrm>
             <a:off x="3650667" y="678114"/>
             <a:ext cx="7620000" cy="5283200"/>
+          </a:xfrm>
+          <a:prstGeom prst="rect">
+            <a:avLst/>
+          </a:prstGeom>
+        </p:spPr>
+      </p:pic>
+      <p:pic>
+        <p:nvPicPr>
+          <p:cNvPr id="2" name="Gráfico 1">
+            <a:extLst>
+              <a:ext uri="{FF2B5EF4-FFF2-40B4-BE49-F238E27FC236}">
+                <a16:creationId xmlns:a16="http://schemas.microsoft.com/office/drawing/2014/main" id="{BB917775-E486-0488-3CF7-DEF29B629BB8}"/>
+              </a:ext>
+            </a:extLst>
+          </p:cNvPr>
+          <p:cNvPicPr>
+            <a:picLocks noChangeAspect="1"/>
+          </p:cNvPicPr>
+          <p:nvPr/>
+        </p:nvPicPr>
+        <p:blipFill>
+          <a:blip r:embed="rId3">
+            <a:extLst>
+              <a:ext uri="{96DAC541-7B7A-43D3-8B79-37D633B846F1}">
+                <asvg:svgBlip xmlns:asvg="http://schemas.microsoft.com/office/drawing/2016/SVG/main" r:embed="rId4"/>
+              </a:ext>
+            </a:extLst>
+          </a:blip>
+          <a:stretch>
+            <a:fillRect/>
+          </a:stretch>
+        </p:blipFill>
+        <p:spPr>
+          <a:xfrm flipH="1" flipV="1">
+            <a:off x="8686800" y="6256679"/>
+            <a:ext cx="3314700" cy="524376"/>
           </a:xfrm>
           <a:prstGeom prst="rect">
             <a:avLst/>
@@ -4248,7 +4397,7 @@
         </p:nvSpPr>
         <p:spPr>
           <a:xfrm>
-            <a:off x="783391" y="918882"/>
+            <a:off x="865687" y="1897290"/>
             <a:ext cx="2988733" cy="1323439"/>
           </a:xfrm>
           <a:prstGeom prst="rect">
@@ -4264,8 +4413,9 @@
           <a:p>
             <a:r>
               <a:rPr lang="es-CO" sz="1600" dirty="0">
-                <a:latin typeface="xkcd Script" panose="03000503000000000000" pitchFamily="66" charset="0"/>
-                <a:ea typeface="xkcd Script" panose="03000503000000000000" pitchFamily="66" charset="0"/>
+                <a:latin typeface="Open Sans" pitchFamily="2" charset="0"/>
+                <a:ea typeface="Open Sans" pitchFamily="2" charset="0"/>
+                <a:cs typeface="Open Sans" pitchFamily="2" charset="0"/>
               </a:rPr>
               <a:t>Generalización espacial del enfoque propuesto para el problema inverso de dominio infinito mediante muestreo uniforme y gaussiano</a:t>
             </a:r>
@@ -4300,8 +4450,44 @@
         </p:blipFill>
         <p:spPr>
           <a:xfrm>
-            <a:off x="5163559" y="560904"/>
+            <a:off x="5081263" y="352633"/>
             <a:ext cx="6245050" cy="5736192"/>
+          </a:xfrm>
+          <a:prstGeom prst="rect">
+            <a:avLst/>
+          </a:prstGeom>
+        </p:spPr>
+      </p:pic>
+      <p:pic>
+        <p:nvPicPr>
+          <p:cNvPr id="2" name="Gráfico 1">
+            <a:extLst>
+              <a:ext uri="{FF2B5EF4-FFF2-40B4-BE49-F238E27FC236}">
+                <a16:creationId xmlns:a16="http://schemas.microsoft.com/office/drawing/2014/main" id="{97837598-D783-0E5A-0427-0F72C6E5DAFF}"/>
+              </a:ext>
+            </a:extLst>
+          </p:cNvPr>
+          <p:cNvPicPr>
+            <a:picLocks noChangeAspect="1"/>
+          </p:cNvPicPr>
+          <p:nvPr/>
+        </p:nvPicPr>
+        <p:blipFill>
+          <a:blip r:embed="rId3">
+            <a:extLst>
+              <a:ext uri="{96DAC541-7B7A-43D3-8B79-37D633B846F1}">
+                <asvg:svgBlip xmlns:asvg="http://schemas.microsoft.com/office/drawing/2016/SVG/main" r:embed="rId4"/>
+              </a:ext>
+            </a:extLst>
+          </a:blip>
+          <a:stretch>
+            <a:fillRect/>
+          </a:stretch>
+        </p:blipFill>
+        <p:spPr>
+          <a:xfrm flipH="1" flipV="1">
+            <a:off x="8753475" y="6275729"/>
+            <a:ext cx="3314700" cy="524376"/>
           </a:xfrm>
           <a:prstGeom prst="rect">
             <a:avLst/>

</xml_diff>

<commit_message>
Add run metrics and summary metrics for KAN model evaluation on 2026-09-14
- Created JSON file with detailed run metrics including model configuration, training time, and error metrics.
- Added CSV summary of model performance across different configurations, including hidden layers and units.
</commit_message>
<xml_diff>
--- a/main/slides_es/resumen-trabajo-amci-4-09-2026.pptx
+++ b/main/slides_es/resumen-trabajo-amci-4-09-2026.pptx
@@ -277,7 +277,7 @@
           <a:p>
             <a:fld id="{E7033D45-214F-4590-AE5F-D6D9CBF27883}" type="datetimeFigureOut">
               <a:rPr lang="es-CO" smtClean="0"/>
-              <a:t>13/09/2026</a:t>
+              <a:t>14/09/2026</a:t>
             </a:fld>
             <a:endParaRPr lang="es-CO"/>
           </a:p>
@@ -477,7 +477,7 @@
           <a:p>
             <a:fld id="{E7033D45-214F-4590-AE5F-D6D9CBF27883}" type="datetimeFigureOut">
               <a:rPr lang="es-CO" smtClean="0"/>
-              <a:t>13/09/2026</a:t>
+              <a:t>14/09/2026</a:t>
             </a:fld>
             <a:endParaRPr lang="es-CO"/>
           </a:p>
@@ -687,7 +687,7 @@
           <a:p>
             <a:fld id="{E7033D45-214F-4590-AE5F-D6D9CBF27883}" type="datetimeFigureOut">
               <a:rPr lang="es-CO" smtClean="0"/>
-              <a:t>13/09/2026</a:t>
+              <a:t>14/09/2026</a:t>
             </a:fld>
             <a:endParaRPr lang="es-CO"/>
           </a:p>
@@ -887,7 +887,7 @@
           <a:p>
             <a:fld id="{E7033D45-214F-4590-AE5F-D6D9CBF27883}" type="datetimeFigureOut">
               <a:rPr lang="es-CO" smtClean="0"/>
-              <a:t>13/09/2026</a:t>
+              <a:t>14/09/2026</a:t>
             </a:fld>
             <a:endParaRPr lang="es-CO"/>
           </a:p>
@@ -1163,7 +1163,7 @@
           <a:p>
             <a:fld id="{E7033D45-214F-4590-AE5F-D6D9CBF27883}" type="datetimeFigureOut">
               <a:rPr lang="es-CO" smtClean="0"/>
-              <a:t>13/09/2026</a:t>
+              <a:t>14/09/2026</a:t>
             </a:fld>
             <a:endParaRPr lang="es-CO"/>
           </a:p>
@@ -1431,7 +1431,7 @@
           <a:p>
             <a:fld id="{E7033D45-214F-4590-AE5F-D6D9CBF27883}" type="datetimeFigureOut">
               <a:rPr lang="es-CO" smtClean="0"/>
-              <a:t>13/09/2026</a:t>
+              <a:t>14/09/2026</a:t>
             </a:fld>
             <a:endParaRPr lang="es-CO"/>
           </a:p>
@@ -1846,7 +1846,7 @@
           <a:p>
             <a:fld id="{E7033D45-214F-4590-AE5F-D6D9CBF27883}" type="datetimeFigureOut">
               <a:rPr lang="es-CO" smtClean="0"/>
-              <a:t>13/09/2026</a:t>
+              <a:t>14/09/2026</a:t>
             </a:fld>
             <a:endParaRPr lang="es-CO"/>
           </a:p>
@@ -1988,7 +1988,7 @@
           <a:p>
             <a:fld id="{E7033D45-214F-4590-AE5F-D6D9CBF27883}" type="datetimeFigureOut">
               <a:rPr lang="es-CO" smtClean="0"/>
-              <a:t>13/09/2026</a:t>
+              <a:t>14/09/2026</a:t>
             </a:fld>
             <a:endParaRPr lang="es-CO"/>
           </a:p>
@@ -2101,7 +2101,7 @@
           <a:p>
             <a:fld id="{E7033D45-214F-4590-AE5F-D6D9CBF27883}" type="datetimeFigureOut">
               <a:rPr lang="es-CO" smtClean="0"/>
-              <a:t>13/09/2026</a:t>
+              <a:t>14/09/2026</a:t>
             </a:fld>
             <a:endParaRPr lang="es-CO"/>
           </a:p>
@@ -2414,7 +2414,7 @@
           <a:p>
             <a:fld id="{E7033D45-214F-4590-AE5F-D6D9CBF27883}" type="datetimeFigureOut">
               <a:rPr lang="es-CO" smtClean="0"/>
-              <a:t>13/09/2026</a:t>
+              <a:t>14/09/2026</a:t>
             </a:fld>
             <a:endParaRPr lang="es-CO"/>
           </a:p>
@@ -2703,7 +2703,7 @@
           <a:p>
             <a:fld id="{E7033D45-214F-4590-AE5F-D6D9CBF27883}" type="datetimeFigureOut">
               <a:rPr lang="es-CO" smtClean="0"/>
-              <a:t>13/09/2026</a:t>
+              <a:t>14/09/2026</a:t>
             </a:fld>
             <a:endParaRPr lang="es-CO"/>
           </a:p>
@@ -2949,7 +2949,7 @@
           <a:p>
             <a:fld id="{E7033D45-214F-4590-AE5F-D6D9CBF27883}" type="datetimeFigureOut">
               <a:rPr lang="es-CO" smtClean="0"/>
-              <a:t>13/09/2026</a:t>
+              <a:t>14/09/2026</a:t>
             </a:fld>
             <a:endParaRPr lang="es-CO"/>
           </a:p>
@@ -3388,7 +3388,7 @@
         </p:nvSpPr>
         <p:spPr>
           <a:xfrm>
-            <a:off x="1333500" y="603624"/>
+            <a:off x="1145241" y="1328360"/>
             <a:ext cx="9525000" cy="1569660"/>
           </a:xfrm>
           <a:prstGeom prst="rect">
@@ -3425,12 +3425,98 @@
           </a:p>
         </p:txBody>
       </p:sp>
+      <p:sp>
+        <p:nvSpPr>
+          <p:cNvPr id="6" name="CuadroTexto 5">
+            <a:extLst>
+              <a:ext uri="{FF2B5EF4-FFF2-40B4-BE49-F238E27FC236}">
+                <a16:creationId xmlns:a16="http://schemas.microsoft.com/office/drawing/2014/main" id="{70241A18-AAD6-4D5F-9AF2-13D545084A6E}"/>
+              </a:ext>
+            </a:extLst>
+          </p:cNvPr>
+          <p:cNvSpPr txBox="1"/>
+          <p:nvPr/>
+        </p:nvSpPr>
+        <p:spPr>
+          <a:xfrm>
+            <a:off x="1266265" y="3267483"/>
+            <a:ext cx="4441540" cy="1384995"/>
+          </a:xfrm>
+          <a:prstGeom prst="rect">
+            <a:avLst/>
+          </a:prstGeom>
+          <a:noFill/>
+        </p:spPr>
+        <p:txBody>
+          <a:bodyPr wrap="square">
+            <a:spAutoFit/>
+          </a:bodyPr>
+          <a:lstStyle/>
+          <a:p>
+            <a:r>
+              <a:rPr lang="es-MX" sz="1400" dirty="0">
+                <a:latin typeface="Open Sans" pitchFamily="2" charset="0"/>
+                <a:ea typeface="Open Sans" pitchFamily="2" charset="0"/>
+                <a:cs typeface="Open Sans" pitchFamily="2" charset="0"/>
+              </a:rPr>
+              <a:t>Oscar Andrés Rincón Cardeño</a:t>
+            </a:r>
+          </a:p>
+          <a:p>
+            <a:r>
+              <a:rPr lang="es-MX" sz="1400" dirty="0">
+                <a:latin typeface="Open Sans" pitchFamily="2" charset="0"/>
+                <a:ea typeface="Open Sans" pitchFamily="2" charset="0"/>
+                <a:cs typeface="Open Sans" pitchFamily="2" charset="0"/>
+              </a:rPr>
+              <a:t>Doctorado en Ingeniería</a:t>
+            </a:r>
+          </a:p>
+          <a:p>
+            <a:endParaRPr lang="es-MX" sz="1400" dirty="0">
+              <a:latin typeface="Open Sans" pitchFamily="2" charset="0"/>
+              <a:ea typeface="Open Sans" pitchFamily="2" charset="0"/>
+              <a:cs typeface="Open Sans" pitchFamily="2" charset="0"/>
+            </a:endParaRPr>
+          </a:p>
+          <a:p>
+            <a:r>
+              <a:rPr lang="es-MX" sz="1400" dirty="0">
+                <a:latin typeface="Open Sans" pitchFamily="2" charset="0"/>
+                <a:ea typeface="Open Sans" pitchFamily="2" charset="0"/>
+                <a:cs typeface="Open Sans" pitchFamily="2" charset="0"/>
+              </a:rPr>
+              <a:t>Aplicaciones Matemáticas en Ciencia e Ingeniería </a:t>
+            </a:r>
+          </a:p>
+          <a:p>
+            <a:r>
+              <a:rPr lang="es-MX" sz="1400" dirty="0">
+                <a:latin typeface="Open Sans" pitchFamily="2" charset="0"/>
+                <a:ea typeface="Open Sans" pitchFamily="2" charset="0"/>
+                <a:cs typeface="Open Sans" pitchFamily="2" charset="0"/>
+              </a:rPr>
+              <a:t>Universidad EAFIT </a:t>
+            </a:r>
+          </a:p>
+          <a:p>
+            <a:r>
+              <a:rPr lang="es-CO" sz="1400" dirty="0">
+                <a:latin typeface="Open Sans" pitchFamily="2" charset="0"/>
+                <a:ea typeface="Open Sans" pitchFamily="2" charset="0"/>
+                <a:cs typeface="Open Sans" pitchFamily="2" charset="0"/>
+              </a:rPr>
+              <a:t>Septiembre del 2026</a:t>
+            </a:r>
+          </a:p>
+        </p:txBody>
+      </p:sp>
       <p:pic>
         <p:nvPicPr>
-          <p:cNvPr id="16" name="Imagen 15" descr="Diagrama, Esquemático&#10;&#10;Descripción generada automáticamente">
-            <a:extLst>
-              <a:ext uri="{FF2B5EF4-FFF2-40B4-BE49-F238E27FC236}">
-                <a16:creationId xmlns:a16="http://schemas.microsoft.com/office/drawing/2014/main" id="{6E0D39BD-00EA-A173-6869-C086EEDC2BB0}"/>
+          <p:cNvPr id="3" name="Imagen 2">
+            <a:extLst>
+              <a:ext uri="{FF2B5EF4-FFF2-40B4-BE49-F238E27FC236}">
+                <a16:creationId xmlns:a16="http://schemas.microsoft.com/office/drawing/2014/main" id="{AC9F1322-5ECA-4632-BF3D-AB2406E2F2A1}"/>
               </a:ext>
             </a:extLst>
           </p:cNvPr>
@@ -3453,100 +3539,14 @@
         </p:blipFill>
         <p:spPr>
           <a:xfrm>
-            <a:off x="5698840" y="2698440"/>
-            <a:ext cx="5235860" cy="3366120"/>
+            <a:off x="5907741" y="2971060"/>
+            <a:ext cx="4765618" cy="2427132"/>
           </a:xfrm>
           <a:prstGeom prst="rect">
             <a:avLst/>
           </a:prstGeom>
         </p:spPr>
       </p:pic>
-      <p:sp>
-        <p:nvSpPr>
-          <p:cNvPr id="6" name="CuadroTexto 5">
-            <a:extLst>
-              <a:ext uri="{FF2B5EF4-FFF2-40B4-BE49-F238E27FC236}">
-                <a16:creationId xmlns:a16="http://schemas.microsoft.com/office/drawing/2014/main" id="{70241A18-AAD6-4D5F-9AF2-13D545084A6E}"/>
-              </a:ext>
-            </a:extLst>
-          </p:cNvPr>
-          <p:cNvSpPr txBox="1"/>
-          <p:nvPr/>
-        </p:nvSpPr>
-        <p:spPr>
-          <a:xfrm>
-            <a:off x="1257300" y="4067557"/>
-            <a:ext cx="4441540" cy="1815882"/>
-          </a:xfrm>
-          <a:prstGeom prst="rect">
-            <a:avLst/>
-          </a:prstGeom>
-          <a:noFill/>
-        </p:spPr>
-        <p:txBody>
-          <a:bodyPr wrap="square">
-            <a:spAutoFit/>
-          </a:bodyPr>
-          <a:lstStyle/>
-          <a:p>
-            <a:r>
-              <a:rPr lang="es-MX" sz="1600" dirty="0">
-                <a:latin typeface="Montserrat" pitchFamily="2" charset="0"/>
-                <a:ea typeface="Open Sans" pitchFamily="2" charset="0"/>
-                <a:cs typeface="Open Sans" pitchFamily="2" charset="0"/>
-              </a:rPr>
-              <a:t>Oscar Andrés Rincón Cardeño</a:t>
-            </a:r>
-          </a:p>
-          <a:p>
-            <a:r>
-              <a:rPr lang="es-MX" sz="1600" dirty="0">
-                <a:latin typeface="Montserrat" pitchFamily="2" charset="0"/>
-                <a:ea typeface="Open Sans" pitchFamily="2" charset="0"/>
-                <a:cs typeface="Open Sans" pitchFamily="2" charset="0"/>
-              </a:rPr>
-              <a:t>Doctorado en Ingeniería</a:t>
-            </a:r>
-          </a:p>
-          <a:p>
-            <a:endParaRPr lang="es-MX" sz="1600" dirty="0">
-              <a:latin typeface="Montserrat" pitchFamily="2" charset="0"/>
-              <a:ea typeface="Open Sans" pitchFamily="2" charset="0"/>
-              <a:cs typeface="Open Sans" pitchFamily="2" charset="0"/>
-            </a:endParaRPr>
-          </a:p>
-          <a:p>
-            <a:r>
-              <a:rPr lang="es-MX" sz="1600" dirty="0">
-                <a:latin typeface="Montserrat" pitchFamily="2" charset="0"/>
-                <a:ea typeface="Open Sans" pitchFamily="2" charset="0"/>
-                <a:cs typeface="Open Sans" pitchFamily="2" charset="0"/>
-              </a:rPr>
-              <a:t>Aplicaciones Matemáticas en Ciencia e Ingeniería </a:t>
-            </a:r>
-          </a:p>
-          <a:p>
-            <a:r>
-              <a:rPr lang="es-MX" sz="1600" dirty="0">
-                <a:latin typeface="Montserrat" pitchFamily="2" charset="0"/>
-                <a:ea typeface="Open Sans" pitchFamily="2" charset="0"/>
-                <a:cs typeface="Open Sans" pitchFamily="2" charset="0"/>
-              </a:rPr>
-              <a:t>Universidad EAFIT </a:t>
-            </a:r>
-          </a:p>
-          <a:p>
-            <a:r>
-              <a:rPr lang="es-CO" sz="1600" dirty="0">
-                <a:latin typeface="Montserrat" pitchFamily="2" charset="0"/>
-                <a:ea typeface="Open Sans" pitchFamily="2" charset="0"/>
-                <a:cs typeface="Open Sans" pitchFamily="2" charset="0"/>
-              </a:rPr>
-              <a:t>Septiembre del 2026</a:t>
-            </a:r>
-          </a:p>
-        </p:txBody>
-      </p:sp>
     </p:spTree>
     <p:extLst>
       <p:ext uri="{BB962C8B-B14F-4D97-AF65-F5344CB8AC3E}">

</xml_diff>